<commit_message>
fix: switch poster orientation
</commit_message>
<xml_diff>
--- a/poster/gemma-lie-detector-poster.pptx
+++ b/poster/gemma-lie-detector-poster.pptx
@@ -10,8 +10,8 @@
   <p:notesMasterIdLst>
     <p:notesMasterId r:id="rId3"/>
   </p:notesMasterIdLst>
-  <p:sldSz cx="21945600" cy="32918400"/>
-  <p:notesSz cx="32918400" cy="21945600"/>
+  <p:sldSz cx="32918400" cy="21945600"/>
+  <p:notesSz cx="21945600" cy="32918400"/>
   <p:defaultTextStyle>
     <a:lvl1pPr marL="0" algn="l" defTabSz="914400" rtl="0" eaLnBrk="1" latinLnBrk="0" hangingPunct="1">
       <a:defRPr sz="1800" kern="1200">
@@ -884,7 +884,7 @@
         <p:spPr>
           <a:xfrm>
             <a:off x="0" y="0"/>
-            <a:ext cx="21945600" cy="3388659"/>
+            <a:ext cx="32918400" cy="2662518"/>
           </a:xfrm>
           <a:prstGeom prst="rect">
             <a:avLst/>
@@ -908,8 +908,8 @@
         </p:nvSpPr>
         <p:spPr>
           <a:xfrm>
-            <a:off x="806824" y="282388"/>
-            <a:ext cx="11295529" cy="1411941"/>
+            <a:off x="806824" y="322729"/>
+            <a:ext cx="18153529" cy="1411941"/>
           </a:xfrm>
           <a:prstGeom prst="rect">
             <a:avLst/>
@@ -925,7 +925,7 @@
               <a:buNone/>
             </a:pPr>
             <a:r>
-              <a:rPr lang="en-US" sz="8900" b="1" dirty="0">
+              <a:rPr lang="en-US" sz="9500" b="1" dirty="0">
                 <a:solidFill>
                   <a:srgbClr val="FFFFFF"/>
                 </a:solidFill>
@@ -935,7 +935,7 @@
               </a:rPr>
               <a:t>Gemma Lie Detector</a:t>
             </a:r>
-            <a:endParaRPr lang="en-US" sz="8900" dirty="0"/>
+            <a:endParaRPr lang="en-US" sz="9500" dirty="0"/>
           </a:p>
         </p:txBody>
       </p:sp>
@@ -947,8 +947,8 @@
         </p:nvSpPr>
         <p:spPr>
           <a:xfrm>
-            <a:off x="806824" y="1653988"/>
-            <a:ext cx="10892118" cy="1129553"/>
+            <a:off x="806824" y="1694329"/>
+            <a:ext cx="18758647" cy="605118"/>
           </a:xfrm>
           <a:prstGeom prst="rect">
             <a:avLst/>
@@ -964,7 +964,7 @@
               <a:buNone/>
             </a:pPr>
             <a:r>
-              <a:rPr lang="en-US" sz="3200" dirty="0">
+              <a:rPr lang="en-US" sz="3800" dirty="0">
                 <a:solidFill>
                   <a:srgbClr val="CADCFC"/>
                 </a:solidFill>
@@ -974,7 +974,7 @@
               </a:rPr>
               <a:t>When Gemma explains a decision by citing words, do those words actually drive it?</a:t>
             </a:r>
-            <a:endParaRPr lang="en-US" sz="3200" dirty="0"/>
+            <a:endParaRPr lang="en-US" sz="3800" dirty="0"/>
           </a:p>
         </p:txBody>
       </p:sp>
@@ -986,8 +986,8 @@
         </p:nvSpPr>
         <p:spPr>
           <a:xfrm>
-            <a:off x="806824" y="2823882"/>
-            <a:ext cx="11295529" cy="403412"/>
+            <a:off x="806824" y="2218765"/>
+            <a:ext cx="18758647" cy="443753"/>
           </a:xfrm>
           <a:prstGeom prst="rect">
             <a:avLst/>
@@ -1003,7 +1003,7 @@
               <a:buNone/>
             </a:pPr>
             <a:r>
-              <a:rPr lang="en-US" sz="2400" dirty="0">
+              <a:rPr lang="en-US" sz="2700" dirty="0">
                 <a:solidFill>
                   <a:srgbClr val="FFFFFF"/>
                 </a:solidFill>
@@ -1013,7 +1013,7 @@
               </a:rPr>
               <a:t>[YOUR NAME]  ·  Duke AIPI  ·  Responsible AI  ·  [DATE]</a:t>
             </a:r>
-            <a:endParaRPr lang="en-US" sz="2400" dirty="0"/>
+            <a:endParaRPr lang="en-US" sz="2700" dirty="0"/>
           </a:p>
         </p:txBody>
       </p:sp>
@@ -1025,8 +1025,8 @@
         </p:nvSpPr>
         <p:spPr>
           <a:xfrm>
-            <a:off x="12263718" y="322729"/>
-            <a:ext cx="8875059" cy="2743200"/>
+            <a:off x="20170588" y="363071"/>
+            <a:ext cx="11940988" cy="1936376"/>
           </a:xfrm>
           <a:prstGeom prst="rect">
             <a:avLst/>
@@ -1050,8 +1050,8 @@
         </p:nvSpPr>
         <p:spPr>
           <a:xfrm>
-            <a:off x="12546106" y="484094"/>
-            <a:ext cx="8310282" cy="2420471"/>
+            <a:off x="20452976" y="484094"/>
+            <a:ext cx="11376212" cy="1694329"/>
           </a:xfrm>
           <a:prstGeom prst="rect">
             <a:avLst/>
@@ -1081,7 +1081,7 @@
               <a:buNone/>
             </a:pPr>
             <a:r>
-              <a:rPr lang="en-US" sz="2200" dirty="0">
+              <a:rPr lang="en-US" sz="2400" dirty="0">
                 <a:solidFill>
                   <a:srgbClr val="CADCFC"/>
                 </a:solidFill>
@@ -1103,7 +1103,7 @@
         </p:nvSpPr>
         <p:spPr>
           <a:xfrm>
-            <a:off x="806824" y="3751729"/>
+            <a:off x="806824" y="3065929"/>
             <a:ext cx="726141" cy="726141"/>
           </a:xfrm>
           <a:prstGeom prst="ellipse">
@@ -1128,7 +1128,7 @@
         </p:nvSpPr>
         <p:spPr>
           <a:xfrm>
-            <a:off x="806824" y="3751729"/>
+            <a:off x="806824" y="3065929"/>
             <a:ext cx="726141" cy="726141"/>
           </a:xfrm>
           <a:prstGeom prst="rect">
@@ -1167,7 +1167,7 @@
         </p:nvSpPr>
         <p:spPr>
           <a:xfrm>
-            <a:off x="1775012" y="3751729"/>
+            <a:off x="1775012" y="3065929"/>
             <a:ext cx="9076765" cy="726141"/>
           </a:xfrm>
           <a:prstGeom prst="rect">
@@ -1206,8 +1206,8 @@
         </p:nvSpPr>
         <p:spPr>
           <a:xfrm>
-            <a:off x="806824" y="4719918"/>
-            <a:ext cx="3186953" cy="1089212"/>
+            <a:off x="806824" y="4034118"/>
+            <a:ext cx="3245246" cy="1089212"/>
           </a:xfrm>
           <a:prstGeom prst="rect">
             <a:avLst/>
@@ -1231,8 +1231,8 @@
         </p:nvSpPr>
         <p:spPr>
           <a:xfrm>
-            <a:off x="1008529" y="4840941"/>
-            <a:ext cx="2783541" cy="322729"/>
+            <a:off x="1008529" y="4155141"/>
+            <a:ext cx="2841834" cy="322729"/>
           </a:xfrm>
           <a:prstGeom prst="rect">
             <a:avLst/>
@@ -1270,8 +1270,8 @@
         </p:nvSpPr>
         <p:spPr>
           <a:xfrm>
-            <a:off x="1008529" y="5204012"/>
-            <a:ext cx="2783541" cy="524435"/>
+            <a:off x="1008529" y="4518212"/>
+            <a:ext cx="2841834" cy="524435"/>
           </a:xfrm>
           <a:prstGeom prst="rect">
             <a:avLst/>
@@ -1309,8 +1309,8 @@
         </p:nvSpPr>
         <p:spPr>
           <a:xfrm>
-            <a:off x="4155141" y="4719918"/>
-            <a:ext cx="3186953" cy="1089212"/>
+            <a:off x="4213434" y="4034118"/>
+            <a:ext cx="3245246" cy="1089212"/>
           </a:xfrm>
           <a:prstGeom prst="rect">
             <a:avLst/>
@@ -1334,8 +1334,8 @@
         </p:nvSpPr>
         <p:spPr>
           <a:xfrm>
-            <a:off x="4356847" y="4840941"/>
-            <a:ext cx="2783541" cy="322729"/>
+            <a:off x="4415140" y="4155141"/>
+            <a:ext cx="2841834" cy="322729"/>
           </a:xfrm>
           <a:prstGeom prst="rect">
             <a:avLst/>
@@ -1373,8 +1373,8 @@
         </p:nvSpPr>
         <p:spPr>
           <a:xfrm>
-            <a:off x="4356847" y="5204012"/>
-            <a:ext cx="2783541" cy="524435"/>
+            <a:off x="4415140" y="4518212"/>
+            <a:ext cx="2841834" cy="524435"/>
           </a:xfrm>
           <a:prstGeom prst="rect">
             <a:avLst/>
@@ -1412,8 +1412,8 @@
         </p:nvSpPr>
         <p:spPr>
           <a:xfrm>
-            <a:off x="7503459" y="4719918"/>
-            <a:ext cx="3186953" cy="1089212"/>
+            <a:off x="7620045" y="4034118"/>
+            <a:ext cx="3245246" cy="1089212"/>
           </a:xfrm>
           <a:prstGeom prst="rect">
             <a:avLst/>
@@ -1437,8 +1437,8 @@
         </p:nvSpPr>
         <p:spPr>
           <a:xfrm>
-            <a:off x="7705165" y="4840941"/>
-            <a:ext cx="2783541" cy="322729"/>
+            <a:off x="7821751" y="4155141"/>
+            <a:ext cx="2841834" cy="322729"/>
           </a:xfrm>
           <a:prstGeom prst="rect">
             <a:avLst/>
@@ -1476,8 +1476,8 @@
         </p:nvSpPr>
         <p:spPr>
           <a:xfrm>
-            <a:off x="7705165" y="5204012"/>
-            <a:ext cx="2783541" cy="524435"/>
+            <a:off x="7821751" y="4518212"/>
+            <a:ext cx="2841834" cy="524435"/>
           </a:xfrm>
           <a:prstGeom prst="rect">
             <a:avLst/>
@@ -1515,8 +1515,8 @@
         </p:nvSpPr>
         <p:spPr>
           <a:xfrm>
-            <a:off x="806824" y="5970494"/>
-            <a:ext cx="9883588" cy="3429000"/>
+            <a:off x="806824" y="5284694"/>
+            <a:ext cx="10058467" cy="2259106"/>
           </a:xfrm>
           <a:prstGeom prst="rect">
             <a:avLst/>
@@ -1540,8 +1540,8 @@
         </p:nvSpPr>
         <p:spPr>
           <a:xfrm>
-            <a:off x="1089212" y="6172200"/>
-            <a:ext cx="9318812" cy="403412"/>
+            <a:off x="1089212" y="5486400"/>
+            <a:ext cx="9493691" cy="403412"/>
           </a:xfrm>
           <a:prstGeom prst="rect">
             <a:avLst/>
@@ -1579,8 +1579,8 @@
         </p:nvSpPr>
         <p:spPr>
           <a:xfrm>
-            <a:off x="1089212" y="6656294"/>
-            <a:ext cx="9318812" cy="2541494"/>
+            <a:off x="1089212" y="5970494"/>
+            <a:ext cx="9493691" cy="1371600"/>
           </a:xfrm>
           <a:prstGeom prst="rect">
             <a:avLst/>
@@ -1664,8 +1664,8 @@
         </p:nvSpPr>
         <p:spPr>
           <a:xfrm>
-            <a:off x="11255188" y="4719918"/>
-            <a:ext cx="9883588" cy="4679576"/>
+            <a:off x="806824" y="7705165"/>
+            <a:ext cx="10058467" cy="4679576"/>
           </a:xfrm>
           <a:prstGeom prst="rect">
             <a:avLst/>
@@ -1689,8 +1689,8 @@
         </p:nvSpPr>
         <p:spPr>
           <a:xfrm>
-            <a:off x="11537576" y="4921624"/>
-            <a:ext cx="9318812" cy="363071"/>
+            <a:off x="1089212" y="7906871"/>
+            <a:ext cx="9493691" cy="363071"/>
           </a:xfrm>
           <a:prstGeom prst="rect">
             <a:avLst/>
@@ -1728,7 +1728,7 @@
         </p:nvSpPr>
         <p:spPr>
           <a:xfrm>
-            <a:off x="11537576" y="5405718"/>
+            <a:off x="1089212" y="8390965"/>
             <a:ext cx="2017059" cy="1008529"/>
           </a:xfrm>
           <a:prstGeom prst="rect">
@@ -1753,7 +1753,7 @@
         </p:nvSpPr>
         <p:spPr>
           <a:xfrm>
-            <a:off x="11537576" y="5405718"/>
+            <a:off x="1089212" y="8390965"/>
             <a:ext cx="2017059" cy="1008529"/>
           </a:xfrm>
           <a:prstGeom prst="rect">
@@ -1792,7 +1792,7 @@
         </p:nvSpPr>
         <p:spPr>
           <a:xfrm>
-            <a:off x="13635318" y="5405718"/>
+            <a:off x="3186953" y="8390965"/>
             <a:ext cx="443753" cy="1008529"/>
           </a:xfrm>
           <a:prstGeom prst="rect">
@@ -1831,8 +1831,8 @@
         </p:nvSpPr>
         <p:spPr>
           <a:xfrm>
-            <a:off x="14159753" y="5405718"/>
-            <a:ext cx="2339788" cy="1008529"/>
+            <a:off x="3711388" y="8390965"/>
+            <a:ext cx="2420471" cy="1008529"/>
           </a:xfrm>
           <a:prstGeom prst="rect">
             <a:avLst/>
@@ -1856,8 +1856,8 @@
         </p:nvSpPr>
         <p:spPr>
           <a:xfrm>
-            <a:off x="14159753" y="5405718"/>
-            <a:ext cx="2339788" cy="1008529"/>
+            <a:off x="3711388" y="8390965"/>
+            <a:ext cx="2420471" cy="1008529"/>
           </a:xfrm>
           <a:prstGeom prst="rect">
             <a:avLst/>
@@ -1895,7 +1895,7 @@
         </p:nvSpPr>
         <p:spPr>
           <a:xfrm>
-            <a:off x="16580224" y="5405718"/>
+            <a:off x="6212541" y="8390965"/>
             <a:ext cx="443753" cy="1008529"/>
           </a:xfrm>
           <a:prstGeom prst="rect">
@@ -1934,8 +1934,8 @@
         </p:nvSpPr>
         <p:spPr>
           <a:xfrm>
-            <a:off x="17104659" y="5405718"/>
-            <a:ext cx="3751729" cy="463924"/>
+            <a:off x="6736976" y="8390965"/>
+            <a:ext cx="3832412" cy="463924"/>
           </a:xfrm>
           <a:prstGeom prst="rect">
             <a:avLst/>
@@ -1959,8 +1959,8 @@
         </p:nvSpPr>
         <p:spPr>
           <a:xfrm>
-            <a:off x="17104659" y="5405718"/>
-            <a:ext cx="3751729" cy="463924"/>
+            <a:off x="6736976" y="8390965"/>
+            <a:ext cx="3832412" cy="463924"/>
           </a:xfrm>
           <a:prstGeom prst="rect">
             <a:avLst/>
@@ -1976,7 +1976,7 @@
               <a:buNone/>
             </a:pPr>
             <a:r>
-              <a:rPr lang="en-US" sz="1700" b="1" dirty="0">
+              <a:rPr lang="en-US" sz="1900" b="1" dirty="0">
                 <a:solidFill>
                   <a:srgbClr val="2A78D6"/>
                 </a:solidFill>
@@ -1986,7 +1986,7 @@
               </a:rPr>
               <a:t>Decision (next-word probabilities)</a:t>
             </a:r>
-            <a:endParaRPr lang="en-US" sz="1700" dirty="0"/>
+            <a:endParaRPr lang="en-US" sz="1900" dirty="0"/>
           </a:p>
         </p:txBody>
       </p:sp>
@@ -1998,8 +1998,8 @@
         </p:nvSpPr>
         <p:spPr>
           <a:xfrm>
-            <a:off x="17104659" y="5950324"/>
-            <a:ext cx="3751729" cy="463924"/>
+            <a:off x="6736976" y="8935571"/>
+            <a:ext cx="3832412" cy="463924"/>
           </a:xfrm>
           <a:prstGeom prst="rect">
             <a:avLst/>
@@ -2023,8 +2023,8 @@
         </p:nvSpPr>
         <p:spPr>
           <a:xfrm>
-            <a:off x="17104659" y="5950324"/>
-            <a:ext cx="3751729" cy="463924"/>
+            <a:off x="6736976" y="8935571"/>
+            <a:ext cx="3832412" cy="463924"/>
           </a:xfrm>
           <a:prstGeom prst="rect">
             <a:avLst/>
@@ -2040,7 +2040,7 @@
               <a:buNone/>
             </a:pPr>
             <a:r>
-              <a:rPr lang="en-US" sz="1700" b="1" dirty="0">
+              <a:rPr lang="en-US" sz="1900" b="1" dirty="0">
                 <a:solidFill>
                   <a:srgbClr val="EB6834"/>
                 </a:solidFill>
@@ -2050,7 +2050,7 @@
               </a:rPr>
               <a:t>Explanation: 3 cited words + reason</a:t>
             </a:r>
-            <a:endParaRPr lang="en-US" sz="1700" dirty="0"/>
+            <a:endParaRPr lang="en-US" sz="1900" dirty="0"/>
           </a:p>
         </p:txBody>
       </p:sp>
@@ -2062,8 +2062,8 @@
         </p:nvSpPr>
         <p:spPr>
           <a:xfrm>
-            <a:off x="11537576" y="6656294"/>
-            <a:ext cx="9318812" cy="443753"/>
+            <a:off x="1089212" y="9641541"/>
+            <a:ext cx="9493691" cy="443753"/>
           </a:xfrm>
           <a:prstGeom prst="rect">
             <a:avLst/>
@@ -2101,8 +2101,8 @@
         </p:nvSpPr>
         <p:spPr>
           <a:xfrm>
-            <a:off x="11537576" y="7221071"/>
-            <a:ext cx="2783541" cy="605118"/>
+            <a:off x="1089212" y="10206318"/>
+            <a:ext cx="2864224" cy="605118"/>
           </a:xfrm>
           <a:prstGeom prst="rect">
             <a:avLst/>
@@ -2126,8 +2126,8 @@
         </p:nvSpPr>
         <p:spPr>
           <a:xfrm>
-            <a:off x="11537576" y="7221071"/>
-            <a:ext cx="2783541" cy="605118"/>
+            <a:off x="1089212" y="10206318"/>
+            <a:ext cx="2864224" cy="605118"/>
           </a:xfrm>
           <a:prstGeom prst="rect">
             <a:avLst/>
@@ -2143,7 +2143,7 @@
               <a:buNone/>
             </a:pPr>
             <a:r>
-              <a:rPr lang="en-US" sz="1700" b="1" dirty="0">
+              <a:rPr lang="en-US" sz="1900" b="1" dirty="0">
                 <a:solidFill>
                   <a:srgbClr val="EB6834"/>
                 </a:solidFill>
@@ -2153,7 +2153,7 @@
               </a:rPr>
               <a:t>Gemma's cited words</a:t>
             </a:r>
-            <a:endParaRPr lang="en-US" sz="1700" dirty="0"/>
+            <a:endParaRPr lang="en-US" sz="1900" dirty="0"/>
           </a:p>
         </p:txBody>
       </p:sp>
@@ -2165,8 +2165,8 @@
         </p:nvSpPr>
         <p:spPr>
           <a:xfrm>
-            <a:off x="14442141" y="7221071"/>
-            <a:ext cx="2985247" cy="605118"/>
+            <a:off x="4074459" y="10206318"/>
+            <a:ext cx="3065929" cy="605118"/>
           </a:xfrm>
           <a:prstGeom prst="rect">
             <a:avLst/>
@@ -2190,8 +2190,8 @@
         </p:nvSpPr>
         <p:spPr>
           <a:xfrm>
-            <a:off x="14442141" y="7221071"/>
-            <a:ext cx="2985247" cy="605118"/>
+            <a:off x="4074459" y="10206318"/>
+            <a:ext cx="3065929" cy="605118"/>
           </a:xfrm>
           <a:prstGeom prst="rect">
             <a:avLst/>
@@ -2207,7 +2207,7 @@
               <a:buNone/>
             </a:pPr>
             <a:r>
-              <a:rPr lang="en-US" sz="1700" b="1" dirty="0">
+              <a:rPr lang="en-US" sz="1900" b="1" dirty="0">
                 <a:solidFill>
                   <a:srgbClr val="2A78D6"/>
                 </a:solidFill>
@@ -2217,7 +2217,7 @@
               </a:rPr>
               <a:t>Occlusion's top words</a:t>
             </a:r>
-            <a:endParaRPr lang="en-US" sz="1700" dirty="0"/>
+            <a:endParaRPr lang="en-US" sz="1900" dirty="0"/>
           </a:p>
         </p:txBody>
       </p:sp>
@@ -2229,8 +2229,8 @@
         </p:nvSpPr>
         <p:spPr>
           <a:xfrm>
-            <a:off x="17548412" y="7221071"/>
-            <a:ext cx="3348318" cy="605118"/>
+            <a:off x="7261412" y="10206318"/>
+            <a:ext cx="3469341" cy="605118"/>
           </a:xfrm>
           <a:prstGeom prst="rect">
             <a:avLst/>
@@ -2254,8 +2254,8 @@
         </p:nvSpPr>
         <p:spPr>
           <a:xfrm>
-            <a:off x="17548412" y="7221071"/>
-            <a:ext cx="3348318" cy="605118"/>
+            <a:off x="7261412" y="10206318"/>
+            <a:ext cx="3469341" cy="605118"/>
           </a:xfrm>
           <a:prstGeom prst="rect">
             <a:avLst/>
@@ -2271,7 +2271,7 @@
               <a:buNone/>
             </a:pPr>
             <a:r>
-              <a:rPr lang="en-US" sz="1700" b="1" dirty="0">
+              <a:rPr lang="en-US" sz="1900" b="1" dirty="0">
                 <a:solidFill>
                   <a:srgbClr val="1BAF7A"/>
                 </a:solidFill>
@@ -2281,7 +2281,7 @@
               </a:rPr>
               <a:t>Integrated gradients' top words</a:t>
             </a:r>
-            <a:endParaRPr lang="en-US" sz="1700" dirty="0"/>
+            <a:endParaRPr lang="en-US" sz="1900" dirty="0"/>
           </a:p>
         </p:txBody>
       </p:sp>
@@ -2293,8 +2293,8 @@
         </p:nvSpPr>
         <p:spPr>
           <a:xfrm>
-            <a:off x="11537576" y="8027894"/>
-            <a:ext cx="9318812" cy="1169894"/>
+            <a:off x="1089212" y="11013141"/>
+            <a:ext cx="9493691" cy="1169894"/>
           </a:xfrm>
           <a:prstGeom prst="rect">
             <a:avLst/>
@@ -2318,8 +2318,8 @@
         </p:nvSpPr>
         <p:spPr>
           <a:xfrm>
-            <a:off x="11739282" y="8108576"/>
-            <a:ext cx="8915400" cy="1008529"/>
+            <a:off x="1290918" y="11093824"/>
+            <a:ext cx="9090279" cy="1008529"/>
           </a:xfrm>
           <a:prstGeom prst="rect">
             <a:avLst/>
@@ -2371,7 +2371,443 @@
         </p:nvSpPr>
         <p:spPr>
           <a:xfrm>
-            <a:off x="806824" y="9641541"/>
+            <a:off x="806824" y="12546106"/>
+            <a:ext cx="10058467" cy="4881282"/>
+          </a:xfrm>
+          <a:prstGeom prst="rect">
+            <a:avLst/>
+          </a:prstGeom>
+          <a:solidFill>
+            <a:srgbClr val="FFFFFF"/>
+          </a:solidFill>
+          <a:ln w="19050">
+            <a:solidFill>
+              <a:srgbClr val="D3D2CC"/>
+            </a:solidFill>
+            <a:prstDash val="solid"/>
+          </a:ln>
+        </p:spPr>
+      </p:sp>
+      <p:sp>
+        <p:nvSpPr>
+          <p:cNvPr id="45" name="Text 43"/>
+          <p:cNvSpPr txBox="1"/>
+          <p:nvPr/>
+        </p:nvSpPr>
+        <p:spPr>
+          <a:xfrm>
+            <a:off x="1089212" y="12747812"/>
+            <a:ext cx="9493691" cy="363071"/>
+          </a:xfrm>
+          <a:prstGeom prst="rect">
+            <a:avLst/>
+          </a:prstGeom>
+          <a:noFill/>
+          <a:ln/>
+        </p:spPr>
+        <p:txBody>
+          <a:bodyPr wrap="square" lIns="0" tIns="0" rIns="0" bIns="0" rtlCol="0" anchor="t"/>
+          <a:lstStyle/>
+          <a:p>
+            <a:pPr algn="l" indent="0" marL="0">
+              <a:buNone/>
+            </a:pPr>
+            <a:r>
+              <a:rPr lang="en-US" sz="1900" b="1" dirty="0">
+                <a:solidFill>
+                  <a:srgbClr val="55544F"/>
+                </a:solidFill>
+                <a:latin typeface="Arial" pitchFamily="34" charset="0"/>
+                <a:ea typeface="Arial" pitchFamily="34" charset="-122"/>
+                <a:cs typeface="Arial" pitchFamily="34" charset="-120"/>
+              </a:rPr>
+              <a:t>ONE REVIEW (sst2-864)</a:t>
+            </a:r>
+            <a:endParaRPr lang="en-US" sz="1900" dirty="0"/>
+          </a:p>
+        </p:txBody>
+      </p:sp>
+      <p:sp>
+        <p:nvSpPr>
+          <p:cNvPr id="46" name="Text 44"/>
+          <p:cNvSpPr txBox="1"/>
+          <p:nvPr/>
+        </p:nvSpPr>
+        <p:spPr>
+          <a:xfrm>
+            <a:off x="1089212" y="13191565"/>
+            <a:ext cx="9493691" cy="605118"/>
+          </a:xfrm>
+          <a:prstGeom prst="rect">
+            <a:avLst/>
+          </a:prstGeom>
+          <a:noFill/>
+          <a:ln/>
+        </p:spPr>
+        <p:txBody>
+          <a:bodyPr wrap="square" lIns="0" tIns="0" rIns="0" bIns="0" rtlCol="0" anchor="t"/>
+          <a:lstStyle/>
+          <a:p>
+            <a:pPr algn="l" indent="0" marL="0">
+              <a:buNone/>
+            </a:pPr>
+            <a:r>
+              <a:rPr lang="en-US" sz="3200" b="1" dirty="0">
+                <a:solidFill>
+                  <a:srgbClr val="2A78D6"/>
+                </a:solidFill>
+                <a:highlight>
+                  <a:srgbClr val="FBD5C3"/>
+                </a:highlight>
+                <a:latin typeface="Calibri" pitchFamily="34" charset="0"/>
+                <a:ea typeface="Calibri" pitchFamily="34" charset="-122"/>
+                <a:cs typeface="Calibri" pitchFamily="34" charset="-120"/>
+              </a:rPr>
+              <a:t>dull</a:t>
+            </a:r>
+            <a:pPr algn="l" indent="0" marL="0">
+              <a:buNone/>
+            </a:pPr>
+            <a:r>
+              <a:rPr lang="en-US" sz="3200" dirty="0">
+                <a:solidFill>
+                  <a:srgbClr val="111110"/>
+                </a:solidFill>
+                <a:latin typeface="Calibri" pitchFamily="34" charset="0"/>
+                <a:ea typeface="Calibri" pitchFamily="34" charset="-122"/>
+                <a:cs typeface="Calibri" pitchFamily="34" charset="-120"/>
+              </a:rPr>
+              <a:t> , </a:t>
+            </a:r>
+            <a:pPr algn="l" indent="0" marL="0">
+              <a:buNone/>
+            </a:pPr>
+            <a:r>
+              <a:rPr lang="en-US" sz="3200" b="1" dirty="0">
+                <a:solidFill>
+                  <a:srgbClr val="2A78D6"/>
+                </a:solidFill>
+                <a:highlight>
+                  <a:srgbClr val="FBD5C3"/>
+                </a:highlight>
+                <a:latin typeface="Calibri" pitchFamily="34" charset="0"/>
+                <a:ea typeface="Calibri" pitchFamily="34" charset="-122"/>
+                <a:cs typeface="Calibri" pitchFamily="34" charset="-120"/>
+              </a:rPr>
+              <a:t>lifeless</a:t>
+            </a:r>
+            <a:pPr algn="l" indent="0" marL="0">
+              <a:buNone/>
+            </a:pPr>
+            <a:r>
+              <a:rPr lang="en-US" sz="3200" dirty="0">
+                <a:solidFill>
+                  <a:srgbClr val="111110"/>
+                </a:solidFill>
+                <a:highlight>
+                  <a:srgbClr val="D3E3F8"/>
+                </a:highlight>
+                <a:latin typeface="Calibri" pitchFamily="34" charset="0"/>
+                <a:ea typeface="Calibri" pitchFamily="34" charset="-122"/>
+                <a:cs typeface="Calibri" pitchFamily="34" charset="-120"/>
+              </a:rPr>
+              <a:t> , </a:t>
+            </a:r>
+            <a:pPr algn="l" indent="0" marL="0">
+              <a:buNone/>
+            </a:pPr>
+            <a:r>
+              <a:rPr lang="en-US" sz="3200" dirty="0">
+                <a:solidFill>
+                  <a:srgbClr val="111110"/>
+                </a:solidFill>
+                <a:latin typeface="Calibri" pitchFamily="34" charset="0"/>
+                <a:ea typeface="Calibri" pitchFamily="34" charset="-122"/>
+                <a:cs typeface="Calibri" pitchFamily="34" charset="-120"/>
+              </a:rPr>
+              <a:t> and </a:t>
+            </a:r>
+            <a:pPr algn="l" indent="0" marL="0">
+              <a:buNone/>
+            </a:pPr>
+            <a:r>
+              <a:rPr lang="en-US" sz="3200" b="1" dirty="0">
+                <a:solidFill>
+                  <a:srgbClr val="111110"/>
+                </a:solidFill>
+                <a:highlight>
+                  <a:srgbClr val="FBD5C3"/>
+                </a:highlight>
+                <a:latin typeface="Calibri" pitchFamily="34" charset="0"/>
+                <a:ea typeface="Calibri" pitchFamily="34" charset="-122"/>
+                <a:cs typeface="Calibri" pitchFamily="34" charset="-120"/>
+              </a:rPr>
+              <a:t>amateurishly</a:t>
+            </a:r>
+            <a:pPr algn="l" indent="0" marL="0">
+              <a:buNone/>
+            </a:pPr>
+            <a:r>
+              <a:rPr lang="en-US" sz="3200" dirty="0">
+                <a:solidFill>
+                  <a:srgbClr val="111110"/>
+                </a:solidFill>
+                <a:latin typeface="Calibri" pitchFamily="34" charset="0"/>
+                <a:ea typeface="Calibri" pitchFamily="34" charset="-122"/>
+                <a:cs typeface="Calibri" pitchFamily="34" charset="-120"/>
+              </a:rPr>
+              <a:t> assembled .</a:t>
+            </a:r>
+            <a:endParaRPr lang="en-US" sz="3200" dirty="0"/>
+          </a:p>
+        </p:txBody>
+      </p:sp>
+      <p:sp>
+        <p:nvSpPr>
+          <p:cNvPr id="47" name="Text 45"/>
+          <p:cNvSpPr txBox="1"/>
+          <p:nvPr/>
+        </p:nvSpPr>
+        <p:spPr>
+          <a:xfrm>
+            <a:off x="1089212" y="13877365"/>
+            <a:ext cx="9493691" cy="685800"/>
+          </a:xfrm>
+          <a:prstGeom prst="rect">
+            <a:avLst/>
+          </a:prstGeom>
+          <a:noFill/>
+          <a:ln/>
+        </p:spPr>
+        <p:txBody>
+          <a:bodyPr wrap="square" lIns="0" tIns="0" rIns="0" bIns="0" rtlCol="0" anchor="t"/>
+          <a:lstStyle/>
+          <a:p>
+            <a:pPr algn="l" indent="0" marL="0">
+              <a:buNone/>
+            </a:pPr>
+            <a:r>
+              <a:rPr lang="en-US" sz="1900" dirty="0">
+                <a:solidFill>
+                  <a:srgbClr val="55544F"/>
+                </a:solidFill>
+                <a:latin typeface="Calibri" pitchFamily="34" charset="0"/>
+                <a:ea typeface="Calibri" pitchFamily="34" charset="-122"/>
+                <a:cs typeface="Calibri" pitchFamily="34" charset="-120"/>
+              </a:rPr>
+              <a:t>Orange highlight = cited by Gemma.  Blue = in occlusion's top 3.  Blue text on orange = both.</a:t>
+            </a:r>
+            <a:endParaRPr lang="en-US" sz="1900" dirty="0"/>
+          </a:p>
+        </p:txBody>
+      </p:sp>
+      <p:sp>
+        <p:nvSpPr>
+          <p:cNvPr id="48" name="Text 46"/>
+          <p:cNvSpPr txBox="1"/>
+          <p:nvPr/>
+        </p:nvSpPr>
+        <p:spPr>
+          <a:xfrm>
+            <a:off x="1089212" y="14603506"/>
+            <a:ext cx="9493691" cy="806824"/>
+          </a:xfrm>
+          <a:prstGeom prst="rect">
+            <a:avLst/>
+          </a:prstGeom>
+          <a:noFill/>
+          <a:ln/>
+        </p:spPr>
+        <p:txBody>
+          <a:bodyPr wrap="square" lIns="0" tIns="0" rIns="0" bIns="0" rtlCol="0" anchor="t"/>
+          <a:lstStyle/>
+          <a:p>
+            <a:pPr algn="l" indent="0" marL="0">
+              <a:buNone/>
+            </a:pPr>
+            <a:r>
+              <a:rPr lang="en-US" sz="2200" b="1" dirty="0">
+                <a:solidFill>
+                  <a:srgbClr val="111110"/>
+                </a:solidFill>
+                <a:latin typeface="Calibri" pitchFamily="34" charset="0"/>
+                <a:ea typeface="Calibri" pitchFamily="34" charset="-122"/>
+                <a:cs typeface="Calibri" pitchFamily="34" charset="-120"/>
+              </a:rPr>
+              <a:t>Gemma says: </a:t>
+            </a:r>
+            <a:pPr algn="l" indent="0" marL="0">
+              <a:buNone/>
+            </a:pPr>
+            <a:r>
+              <a:rPr lang="en-US" sz="2200" i="1" dirty="0">
+                <a:solidFill>
+                  <a:srgbClr val="111110"/>
+                </a:solidFill>
+                <a:latin typeface="Calibri" pitchFamily="34" charset="0"/>
+                <a:ea typeface="Calibri" pitchFamily="34" charset="-122"/>
+                <a:cs typeface="Calibri" pitchFamily="34" charset="-120"/>
+              </a:rPr>
+              <a:t>"The review uses strongly negative descriptors to describe the film."</a:t>
+            </a:r>
+            <a:endParaRPr lang="en-US" sz="2200" dirty="0"/>
+          </a:p>
+        </p:txBody>
+      </p:sp>
+      <p:sp>
+        <p:nvSpPr>
+          <p:cNvPr id="49" name="Text 47"/>
+          <p:cNvSpPr txBox="1"/>
+          <p:nvPr/>
+        </p:nvSpPr>
+        <p:spPr>
+          <a:xfrm>
+            <a:off x="1089212" y="15491012"/>
+            <a:ext cx="9493691" cy="443753"/>
+          </a:xfrm>
+          <a:prstGeom prst="rect">
+            <a:avLst/>
+          </a:prstGeom>
+          <a:noFill/>
+          <a:ln/>
+        </p:spPr>
+        <p:txBody>
+          <a:bodyPr wrap="square" lIns="0" tIns="0" rIns="0" bIns="0" rtlCol="0" anchor="t"/>
+          <a:lstStyle/>
+          <a:p>
+            <a:pPr algn="l" indent="0" marL="0">
+              <a:buNone/>
+            </a:pPr>
+            <a:r>
+              <a:rPr lang="en-US" sz="2200" b="1" dirty="0">
+                <a:solidFill>
+                  <a:srgbClr val="EB6834"/>
+                </a:solidFill>
+                <a:latin typeface="Calibri" pitchFamily="34" charset="0"/>
+                <a:ea typeface="Calibri" pitchFamily="34" charset="-122"/>
+                <a:cs typeface="Calibri" pitchFamily="34" charset="-120"/>
+              </a:rPr>
+              <a:t>Delete Gemma's 3 cited words: </a:t>
+            </a:r>
+            <a:pPr algn="l" indent="0" marL="0">
+              <a:buNone/>
+            </a:pPr>
+            <a:r>
+              <a:rPr lang="en-US" sz="2200" dirty="0">
+                <a:solidFill>
+                  <a:srgbClr val="111110"/>
+                </a:solidFill>
+                <a:latin typeface="Calibri" pitchFamily="34" charset="0"/>
+                <a:ea typeface="Calibri" pitchFamily="34" charset="-122"/>
+                <a:cs typeface="Calibri" pitchFamily="34" charset="-120"/>
+              </a:rPr>
+              <a:t>margin 27.0 → −12.0, decision flips.</a:t>
+            </a:r>
+            <a:endParaRPr lang="en-US" sz="2200" dirty="0"/>
+          </a:p>
+        </p:txBody>
+      </p:sp>
+      <p:sp>
+        <p:nvSpPr>
+          <p:cNvPr id="50" name="Text 48"/>
+          <p:cNvSpPr txBox="1"/>
+          <p:nvPr/>
+        </p:nvSpPr>
+        <p:spPr>
+          <a:xfrm>
+            <a:off x="1089212" y="16015447"/>
+            <a:ext cx="9493691" cy="443753"/>
+          </a:xfrm>
+          <a:prstGeom prst="rect">
+            <a:avLst/>
+          </a:prstGeom>
+          <a:noFill/>
+          <a:ln/>
+        </p:spPr>
+        <p:txBody>
+          <a:bodyPr wrap="square" lIns="0" tIns="0" rIns="0" bIns="0" rtlCol="0" anchor="t"/>
+          <a:lstStyle/>
+          <a:p>
+            <a:pPr algn="l" indent="0" marL="0">
+              <a:buNone/>
+            </a:pPr>
+            <a:r>
+              <a:rPr lang="en-US" sz="2200" b="1" dirty="0">
+                <a:solidFill>
+                  <a:srgbClr val="2A78D6"/>
+                </a:solidFill>
+                <a:latin typeface="Calibri" pitchFamily="34" charset="0"/>
+                <a:ea typeface="Calibri" pitchFamily="34" charset="-122"/>
+                <a:cs typeface="Calibri" pitchFamily="34" charset="-120"/>
+              </a:rPr>
+              <a:t>Delete occlusion's top 3 words: </a:t>
+            </a:r>
+            <a:pPr algn="l" indent="0" marL="0">
+              <a:buNone/>
+            </a:pPr>
+            <a:r>
+              <a:rPr lang="en-US" sz="2200" dirty="0">
+                <a:solidFill>
+                  <a:srgbClr val="111110"/>
+                </a:solidFill>
+                <a:latin typeface="Calibri" pitchFamily="34" charset="0"/>
+                <a:ea typeface="Calibri" pitchFamily="34" charset="-122"/>
+                <a:cs typeface="Calibri" pitchFamily="34" charset="-120"/>
+              </a:rPr>
+              <a:t>margin 27.0 → 25.8, decision stays.</a:t>
+            </a:r>
+            <a:endParaRPr lang="en-US" sz="2200" dirty="0"/>
+          </a:p>
+        </p:txBody>
+      </p:sp>
+      <p:sp>
+        <p:nvSpPr>
+          <p:cNvPr id="51" name="Text 49"/>
+          <p:cNvSpPr txBox="1"/>
+          <p:nvPr/>
+        </p:nvSpPr>
+        <p:spPr>
+          <a:xfrm>
+            <a:off x="1089212" y="16580224"/>
+            <a:ext cx="9493691" cy="685800"/>
+          </a:xfrm>
+          <a:prstGeom prst="rect">
+            <a:avLst/>
+          </a:prstGeom>
+          <a:noFill/>
+          <a:ln/>
+        </p:spPr>
+        <p:txBody>
+          <a:bodyPr wrap="square" lIns="0" tIns="0" rIns="0" bIns="0" rtlCol="0" anchor="t"/>
+          <a:lstStyle/>
+          <a:p>
+            <a:pPr algn="l" indent="0" marL="0">
+              <a:buNone/>
+            </a:pPr>
+            <a:r>
+              <a:rPr lang="en-US" sz="1900" i="1" dirty="0">
+                <a:solidFill>
+                  <a:srgbClr val="55544F"/>
+                </a:solidFill>
+                <a:latin typeface="Calibri" pitchFamily="34" charset="0"/>
+                <a:ea typeface="Calibri" pitchFamily="34" charset="-122"/>
+                <a:cs typeface="Calibri" pitchFamily="34" charset="-120"/>
+              </a:rPr>
+              <a:t>Gemma's citations beat occlusion's top words in 24 of 300 reviews; the reverse happens in 53.</a:t>
+            </a:r>
+            <a:endParaRPr lang="en-US" sz="1900" dirty="0"/>
+          </a:p>
+        </p:txBody>
+      </p:sp>
+      <p:sp>
+        <p:nvSpPr>
+          <p:cNvPr id="52" name="Shape 50"/>
+          <p:cNvSpPr/>
+          <p:nvPr/>
+        </p:nvSpPr>
+        <p:spPr>
+          <a:xfrm>
+            <a:off x="11430067" y="3065929"/>
             <a:ext cx="726141" cy="726141"/>
           </a:xfrm>
           <a:prstGeom prst="ellipse">
@@ -2390,13 +2826,13 @@
       </p:sp>
       <p:sp>
         <p:nvSpPr>
-          <p:cNvPr id="45" name="Text 43"/>
-          <p:cNvSpPr txBox="1"/>
-          <p:nvPr/>
-        </p:nvSpPr>
-        <p:spPr>
-          <a:xfrm>
-            <a:off x="806824" y="9641541"/>
+          <p:cNvPr id="53" name="Text 51"/>
+          <p:cNvSpPr txBox="1"/>
+          <p:nvPr/>
+        </p:nvSpPr>
+        <p:spPr>
+          <a:xfrm>
+            <a:off x="11430067" y="3065929"/>
             <a:ext cx="726141" cy="726141"/>
           </a:xfrm>
           <a:prstGeom prst="rect">
@@ -2429,13 +2865,13 @@
       </p:sp>
       <p:sp>
         <p:nvSpPr>
-          <p:cNvPr id="46" name="Text 44"/>
-          <p:cNvSpPr txBox="1"/>
-          <p:nvPr/>
-        </p:nvSpPr>
-        <p:spPr>
-          <a:xfrm>
-            <a:off x="1775012" y="9641541"/>
+          <p:cNvPr id="54" name="Text 52"/>
+          <p:cNvSpPr txBox="1"/>
+          <p:nvPr/>
+        </p:nvSpPr>
+        <p:spPr>
+          <a:xfrm>
+            <a:off x="12398255" y="3065929"/>
             <a:ext cx="9076765" cy="726141"/>
           </a:xfrm>
           <a:prstGeom prst="rect">
@@ -2468,14 +2904,14 @@
       </p:sp>
       <p:sp>
         <p:nvSpPr>
-          <p:cNvPr id="47" name="Shape 45"/>
+          <p:cNvPr id="55" name="Shape 53"/>
           <p:cNvSpPr/>
           <p:nvPr/>
         </p:nvSpPr>
         <p:spPr>
           <a:xfrm>
-            <a:off x="806824" y="10609729"/>
-            <a:ext cx="9883588" cy="6373906"/>
+            <a:off x="11430067" y="4034118"/>
+            <a:ext cx="10058467" cy="5446059"/>
           </a:xfrm>
           <a:prstGeom prst="rect">
             <a:avLst/>
@@ -2493,7 +2929,7 @@
       </p:sp>
       <p:pic>
         <p:nvPicPr>
-          <p:cNvPr id="48" name="Image 0" descr="Bar chart: share of reviews where deleting words flips the decision, for random, cited, occlusion and integrated-gradients words">    </p:cNvPr>
+          <p:cNvPr id="56" name="Image 0" descr="Bar chart: share of reviews where deleting words flips the decision, for random, cited, occlusion and integrated-gradients words">    </p:cNvPr>
           <p:cNvPicPr>
             <a:picLocks noChangeAspect="1"/>
           </p:cNvPicPr>
@@ -2507,8 +2943,8 @@
         </p:blipFill>
         <p:spPr>
           <a:xfrm>
-            <a:off x="1411941" y="10716438"/>
-            <a:ext cx="8673353" cy="6160489"/>
+            <a:off x="12727742" y="4106704"/>
+            <a:ext cx="7463118" cy="5300886"/>
           </a:xfrm>
           <a:prstGeom prst="rect">
             <a:avLst/>
@@ -2517,14 +2953,14 @@
       </p:pic>
       <p:sp>
         <p:nvSpPr>
-          <p:cNvPr id="49" name="Shape 46"/>
+          <p:cNvPr id="57" name="Shape 54"/>
           <p:cNvSpPr/>
           <p:nvPr/>
         </p:nvSpPr>
         <p:spPr>
           <a:xfrm>
-            <a:off x="11255188" y="10609729"/>
-            <a:ext cx="9883588" cy="5284694"/>
+            <a:off x="11430067" y="9641541"/>
+            <a:ext cx="10058467" cy="4679576"/>
           </a:xfrm>
           <a:prstGeom prst="rect">
             <a:avLst/>
@@ -2542,7 +2978,7 @@
       </p:sp>
       <p:pic>
         <p:nvPicPr>
-          <p:cNvPr id="50" name="Image 1" descr="Line chart: margin of the original decision as top-ranked words are deleted one by one">    </p:cNvPr>
+          <p:cNvPr id="58" name="Image 1" descr="Line chart: margin of the original decision as top-ranked words are deleted one by one">    </p:cNvPr>
           <p:cNvPicPr>
             <a:picLocks noChangeAspect="1"/>
           </p:cNvPicPr>
@@ -2556,8 +2992,8 @@
         </p:blipFill>
         <p:spPr>
           <a:xfrm>
-            <a:off x="11860306" y="10650123"/>
-            <a:ext cx="8673353" cy="5203908"/>
+            <a:off x="12727742" y="9742439"/>
+            <a:ext cx="7463118" cy="4477781"/>
           </a:xfrm>
           <a:prstGeom prst="rect">
             <a:avLst/>
@@ -2566,14 +3002,14 @@
       </p:pic>
       <p:sp>
         <p:nvSpPr>
-          <p:cNvPr id="51" name="Shape 47"/>
+          <p:cNvPr id="59" name="Shape 55"/>
           <p:cNvSpPr/>
           <p:nvPr/>
         </p:nvSpPr>
         <p:spPr>
           <a:xfrm>
-            <a:off x="11255188" y="16055788"/>
-            <a:ext cx="9883588" cy="5768788"/>
+            <a:off x="11430067" y="14482482"/>
+            <a:ext cx="10058467" cy="2944906"/>
           </a:xfrm>
           <a:prstGeom prst="rect">
             <a:avLst/>
@@ -2591,14 +3027,14 @@
       </p:sp>
       <p:sp>
         <p:nvSpPr>
-          <p:cNvPr id="52" name="Text 48"/>
-          <p:cNvSpPr txBox="1"/>
-          <p:nvPr/>
-        </p:nvSpPr>
-        <p:spPr>
-          <a:xfrm>
-            <a:off x="11537576" y="16257494"/>
-            <a:ext cx="9318812" cy="403412"/>
+          <p:cNvPr id="60" name="Text 56"/>
+          <p:cNvSpPr txBox="1"/>
+          <p:nvPr/>
+        </p:nvSpPr>
+        <p:spPr>
+          <a:xfrm>
+            <a:off x="11712455" y="14684188"/>
+            <a:ext cx="9493691" cy="403412"/>
           </a:xfrm>
           <a:prstGeom prst="rect">
             <a:avLst/>
@@ -2630,14 +3066,14 @@
       </p:sp>
       <p:sp>
         <p:nvSpPr>
-          <p:cNvPr id="53" name="Text 49"/>
-          <p:cNvSpPr txBox="1"/>
-          <p:nvPr/>
-        </p:nvSpPr>
-        <p:spPr>
-          <a:xfrm>
-            <a:off x="11537576" y="16741588"/>
-            <a:ext cx="9318812" cy="4881282"/>
+          <p:cNvPr id="61" name="Text 57"/>
+          <p:cNvSpPr txBox="1"/>
+          <p:nvPr/>
+        </p:nvSpPr>
+        <p:spPr>
+          <a:xfrm>
+            <a:off x="11712455" y="15168282"/>
+            <a:ext cx="9493691" cy="2057400"/>
           </a:xfrm>
           <a:prstGeom prst="rect">
             <a:avLst/>
@@ -2715,449 +3151,13 @@
       </p:sp>
       <p:sp>
         <p:nvSpPr>
-          <p:cNvPr id="54" name="Shape 50"/>
-          <p:cNvSpPr/>
-          <p:nvPr/>
-        </p:nvSpPr>
-        <p:spPr>
-          <a:xfrm>
-            <a:off x="806824" y="17145000"/>
-            <a:ext cx="9883588" cy="4679576"/>
-          </a:xfrm>
-          <a:prstGeom prst="rect">
-            <a:avLst/>
-          </a:prstGeom>
-          <a:solidFill>
-            <a:srgbClr val="FFFFFF"/>
-          </a:solidFill>
-          <a:ln w="19050">
-            <a:solidFill>
-              <a:srgbClr val="D3D2CC"/>
-            </a:solidFill>
-            <a:prstDash val="solid"/>
-          </a:ln>
-        </p:spPr>
-      </p:sp>
-      <p:sp>
-        <p:nvSpPr>
-          <p:cNvPr id="55" name="Text 51"/>
-          <p:cNvSpPr txBox="1"/>
-          <p:nvPr/>
-        </p:nvSpPr>
-        <p:spPr>
-          <a:xfrm>
-            <a:off x="1089212" y="17346706"/>
-            <a:ext cx="9318812" cy="363071"/>
-          </a:xfrm>
-          <a:prstGeom prst="rect">
-            <a:avLst/>
-          </a:prstGeom>
-          <a:noFill/>
-          <a:ln/>
-        </p:spPr>
-        <p:txBody>
-          <a:bodyPr wrap="square" lIns="0" tIns="0" rIns="0" bIns="0" rtlCol="0" anchor="t"/>
-          <a:lstStyle/>
-          <a:p>
-            <a:pPr algn="l" indent="0" marL="0">
-              <a:buNone/>
-            </a:pPr>
-            <a:r>
-              <a:rPr lang="en-US" sz="1900" b="1" dirty="0">
-                <a:solidFill>
-                  <a:srgbClr val="55544F"/>
-                </a:solidFill>
-                <a:latin typeface="Arial" pitchFamily="34" charset="0"/>
-                <a:ea typeface="Arial" pitchFamily="34" charset="-122"/>
-                <a:cs typeface="Arial" pitchFamily="34" charset="-120"/>
-              </a:rPr>
-              <a:t>ONE REVIEW (sst2-864)</a:t>
-            </a:r>
-            <a:endParaRPr lang="en-US" sz="1900" dirty="0"/>
-          </a:p>
-        </p:txBody>
-      </p:sp>
-      <p:sp>
-        <p:nvSpPr>
-          <p:cNvPr id="56" name="Text 52"/>
-          <p:cNvSpPr txBox="1"/>
-          <p:nvPr/>
-        </p:nvSpPr>
-        <p:spPr>
-          <a:xfrm>
-            <a:off x="1089212" y="17790459"/>
-            <a:ext cx="9318812" cy="605118"/>
-          </a:xfrm>
-          <a:prstGeom prst="rect">
-            <a:avLst/>
-          </a:prstGeom>
-          <a:noFill/>
-          <a:ln/>
-        </p:spPr>
-        <p:txBody>
-          <a:bodyPr wrap="square" lIns="0" tIns="0" rIns="0" bIns="0" rtlCol="0" anchor="t"/>
-          <a:lstStyle/>
-          <a:p>
-            <a:pPr algn="l" indent="0" marL="0">
-              <a:buNone/>
-            </a:pPr>
-            <a:r>
-              <a:rPr lang="en-US" sz="3200" b="1" dirty="0">
-                <a:solidFill>
-                  <a:srgbClr val="2A78D6"/>
-                </a:solidFill>
-                <a:highlight>
-                  <a:srgbClr val="FBD5C3"/>
-                </a:highlight>
-                <a:latin typeface="Calibri" pitchFamily="34" charset="0"/>
-                <a:ea typeface="Calibri" pitchFamily="34" charset="-122"/>
-                <a:cs typeface="Calibri" pitchFamily="34" charset="-120"/>
-              </a:rPr>
-              <a:t>dull</a:t>
-            </a:r>
-            <a:pPr algn="l" indent="0" marL="0">
-              <a:buNone/>
-            </a:pPr>
-            <a:r>
-              <a:rPr lang="en-US" sz="3200" dirty="0">
-                <a:solidFill>
-                  <a:srgbClr val="111110"/>
-                </a:solidFill>
-                <a:latin typeface="Calibri" pitchFamily="34" charset="0"/>
-                <a:ea typeface="Calibri" pitchFamily="34" charset="-122"/>
-                <a:cs typeface="Calibri" pitchFamily="34" charset="-120"/>
-              </a:rPr>
-              <a:t> , </a:t>
-            </a:r>
-            <a:pPr algn="l" indent="0" marL="0">
-              <a:buNone/>
-            </a:pPr>
-            <a:r>
-              <a:rPr lang="en-US" sz="3200" b="1" dirty="0">
-                <a:solidFill>
-                  <a:srgbClr val="2A78D6"/>
-                </a:solidFill>
-                <a:highlight>
-                  <a:srgbClr val="FBD5C3"/>
-                </a:highlight>
-                <a:latin typeface="Calibri" pitchFamily="34" charset="0"/>
-                <a:ea typeface="Calibri" pitchFamily="34" charset="-122"/>
-                <a:cs typeface="Calibri" pitchFamily="34" charset="-120"/>
-              </a:rPr>
-              <a:t>lifeless</a:t>
-            </a:r>
-            <a:pPr algn="l" indent="0" marL="0">
-              <a:buNone/>
-            </a:pPr>
-            <a:r>
-              <a:rPr lang="en-US" sz="3200" dirty="0">
-                <a:solidFill>
-                  <a:srgbClr val="111110"/>
-                </a:solidFill>
-                <a:highlight>
-                  <a:srgbClr val="D3E3F8"/>
-                </a:highlight>
-                <a:latin typeface="Calibri" pitchFamily="34" charset="0"/>
-                <a:ea typeface="Calibri" pitchFamily="34" charset="-122"/>
-                <a:cs typeface="Calibri" pitchFamily="34" charset="-120"/>
-              </a:rPr>
-              <a:t> , </a:t>
-            </a:r>
-            <a:pPr algn="l" indent="0" marL="0">
-              <a:buNone/>
-            </a:pPr>
-            <a:r>
-              <a:rPr lang="en-US" sz="3200" dirty="0">
-                <a:solidFill>
-                  <a:srgbClr val="111110"/>
-                </a:solidFill>
-                <a:latin typeface="Calibri" pitchFamily="34" charset="0"/>
-                <a:ea typeface="Calibri" pitchFamily="34" charset="-122"/>
-                <a:cs typeface="Calibri" pitchFamily="34" charset="-120"/>
-              </a:rPr>
-              <a:t> and </a:t>
-            </a:r>
-            <a:pPr algn="l" indent="0" marL="0">
-              <a:buNone/>
-            </a:pPr>
-            <a:r>
-              <a:rPr lang="en-US" sz="3200" b="1" dirty="0">
-                <a:solidFill>
-                  <a:srgbClr val="111110"/>
-                </a:solidFill>
-                <a:highlight>
-                  <a:srgbClr val="FBD5C3"/>
-                </a:highlight>
-                <a:latin typeface="Calibri" pitchFamily="34" charset="0"/>
-                <a:ea typeface="Calibri" pitchFamily="34" charset="-122"/>
-                <a:cs typeface="Calibri" pitchFamily="34" charset="-120"/>
-              </a:rPr>
-              <a:t>amateurishly</a:t>
-            </a:r>
-            <a:pPr algn="l" indent="0" marL="0">
-              <a:buNone/>
-            </a:pPr>
-            <a:r>
-              <a:rPr lang="en-US" sz="3200" dirty="0">
-                <a:solidFill>
-                  <a:srgbClr val="111110"/>
-                </a:solidFill>
-                <a:latin typeface="Calibri" pitchFamily="34" charset="0"/>
-                <a:ea typeface="Calibri" pitchFamily="34" charset="-122"/>
-                <a:cs typeface="Calibri" pitchFamily="34" charset="-120"/>
-              </a:rPr>
-              <a:t> assembled .</a:t>
-            </a:r>
-            <a:endParaRPr lang="en-US" sz="3200" dirty="0"/>
-          </a:p>
-        </p:txBody>
-      </p:sp>
-      <p:sp>
-        <p:nvSpPr>
-          <p:cNvPr id="57" name="Text 53"/>
-          <p:cNvSpPr txBox="1"/>
-          <p:nvPr/>
-        </p:nvSpPr>
-        <p:spPr>
-          <a:xfrm>
-            <a:off x="1089212" y="18435918"/>
-            <a:ext cx="9318812" cy="645459"/>
-          </a:xfrm>
-          <a:prstGeom prst="rect">
-            <a:avLst/>
-          </a:prstGeom>
-          <a:noFill/>
-          <a:ln/>
-        </p:spPr>
-        <p:txBody>
-          <a:bodyPr wrap="square" lIns="0" tIns="0" rIns="0" bIns="0" rtlCol="0" anchor="t"/>
-          <a:lstStyle/>
-          <a:p>
-            <a:pPr algn="l" indent="0" marL="0">
-              <a:buNone/>
-            </a:pPr>
-            <a:r>
-              <a:rPr lang="en-US" sz="1900" dirty="0">
-                <a:solidFill>
-                  <a:srgbClr val="55544F"/>
-                </a:solidFill>
-                <a:latin typeface="Calibri" pitchFamily="34" charset="0"/>
-                <a:ea typeface="Calibri" pitchFamily="34" charset="-122"/>
-                <a:cs typeface="Calibri" pitchFamily="34" charset="-120"/>
-              </a:rPr>
-              <a:t>Orange highlight = cited by Gemma.  Blue = in occlusion's top 3.  Blue text on orange = both.</a:t>
-            </a:r>
-            <a:endParaRPr lang="en-US" sz="1900" dirty="0"/>
-          </a:p>
-        </p:txBody>
-      </p:sp>
-      <p:sp>
-        <p:nvSpPr>
-          <p:cNvPr id="58" name="Text 54"/>
-          <p:cNvSpPr txBox="1"/>
-          <p:nvPr/>
-        </p:nvSpPr>
-        <p:spPr>
-          <a:xfrm>
-            <a:off x="1089212" y="19121718"/>
-            <a:ext cx="9318812" cy="726141"/>
-          </a:xfrm>
-          <a:prstGeom prst="rect">
-            <a:avLst/>
-          </a:prstGeom>
-          <a:noFill/>
-          <a:ln/>
-        </p:spPr>
-        <p:txBody>
-          <a:bodyPr wrap="square" lIns="0" tIns="0" rIns="0" bIns="0" rtlCol="0" anchor="t"/>
-          <a:lstStyle/>
-          <a:p>
-            <a:pPr algn="l" indent="0" marL="0">
-              <a:buNone/>
-            </a:pPr>
-            <a:r>
-              <a:rPr lang="en-US" sz="2200" b="1" dirty="0">
-                <a:solidFill>
-                  <a:srgbClr val="111110"/>
-                </a:solidFill>
-                <a:latin typeface="Calibri" pitchFamily="34" charset="0"/>
-                <a:ea typeface="Calibri" pitchFamily="34" charset="-122"/>
-                <a:cs typeface="Calibri" pitchFamily="34" charset="-120"/>
-              </a:rPr>
-              <a:t>Gemma says: </a:t>
-            </a:r>
-            <a:pPr algn="l" indent="0" marL="0">
-              <a:buNone/>
-            </a:pPr>
-            <a:r>
-              <a:rPr lang="en-US" sz="2200" i="1" dirty="0">
-                <a:solidFill>
-                  <a:srgbClr val="111110"/>
-                </a:solidFill>
-                <a:latin typeface="Calibri" pitchFamily="34" charset="0"/>
-                <a:ea typeface="Calibri" pitchFamily="34" charset="-122"/>
-                <a:cs typeface="Calibri" pitchFamily="34" charset="-120"/>
-              </a:rPr>
-              <a:t>"The review uses strongly negative descriptors to describe the film."</a:t>
-            </a:r>
-            <a:endParaRPr lang="en-US" sz="2200" dirty="0"/>
-          </a:p>
-        </p:txBody>
-      </p:sp>
-      <p:sp>
-        <p:nvSpPr>
-          <p:cNvPr id="59" name="Text 55"/>
-          <p:cNvSpPr txBox="1"/>
-          <p:nvPr/>
-        </p:nvSpPr>
-        <p:spPr>
-          <a:xfrm>
-            <a:off x="1089212" y="19968882"/>
-            <a:ext cx="9318812" cy="443753"/>
-          </a:xfrm>
-          <a:prstGeom prst="rect">
-            <a:avLst/>
-          </a:prstGeom>
-          <a:noFill/>
-          <a:ln/>
-        </p:spPr>
-        <p:txBody>
-          <a:bodyPr wrap="square" lIns="0" tIns="0" rIns="0" bIns="0" rtlCol="0" anchor="t"/>
-          <a:lstStyle/>
-          <a:p>
-            <a:pPr algn="l" indent="0" marL="0">
-              <a:buNone/>
-            </a:pPr>
-            <a:r>
-              <a:rPr lang="en-US" sz="2200" b="1" dirty="0">
-                <a:solidFill>
-                  <a:srgbClr val="EB6834"/>
-                </a:solidFill>
-                <a:latin typeface="Calibri" pitchFamily="34" charset="0"/>
-                <a:ea typeface="Calibri" pitchFamily="34" charset="-122"/>
-                <a:cs typeface="Calibri" pitchFamily="34" charset="-120"/>
-              </a:rPr>
-              <a:t>Delete Gemma's 3 cited words: </a:t>
-            </a:r>
-            <a:pPr algn="l" indent="0" marL="0">
-              <a:buNone/>
-            </a:pPr>
-            <a:r>
-              <a:rPr lang="en-US" sz="2200" dirty="0">
-                <a:solidFill>
-                  <a:srgbClr val="111110"/>
-                </a:solidFill>
-                <a:latin typeface="Calibri" pitchFamily="34" charset="0"/>
-                <a:ea typeface="Calibri" pitchFamily="34" charset="-122"/>
-                <a:cs typeface="Calibri" pitchFamily="34" charset="-120"/>
-              </a:rPr>
-              <a:t>margin 27.0 → −12.0, decision flips.</a:t>
-            </a:r>
-            <a:endParaRPr lang="en-US" sz="2200" dirty="0"/>
-          </a:p>
-        </p:txBody>
-      </p:sp>
-      <p:sp>
-        <p:nvSpPr>
-          <p:cNvPr id="60" name="Text 56"/>
-          <p:cNvSpPr txBox="1"/>
-          <p:nvPr/>
-        </p:nvSpPr>
-        <p:spPr>
-          <a:xfrm>
-            <a:off x="1089212" y="20493318"/>
-            <a:ext cx="9318812" cy="443753"/>
-          </a:xfrm>
-          <a:prstGeom prst="rect">
-            <a:avLst/>
-          </a:prstGeom>
-          <a:noFill/>
-          <a:ln/>
-        </p:spPr>
-        <p:txBody>
-          <a:bodyPr wrap="square" lIns="0" tIns="0" rIns="0" bIns="0" rtlCol="0" anchor="t"/>
-          <a:lstStyle/>
-          <a:p>
-            <a:pPr algn="l" indent="0" marL="0">
-              <a:buNone/>
-            </a:pPr>
-            <a:r>
-              <a:rPr lang="en-US" sz="2200" b="1" dirty="0">
-                <a:solidFill>
-                  <a:srgbClr val="2A78D6"/>
-                </a:solidFill>
-                <a:latin typeface="Calibri" pitchFamily="34" charset="0"/>
-                <a:ea typeface="Calibri" pitchFamily="34" charset="-122"/>
-                <a:cs typeface="Calibri" pitchFamily="34" charset="-120"/>
-              </a:rPr>
-              <a:t>Delete occlusion's top 3 words: </a:t>
-            </a:r>
-            <a:pPr algn="l" indent="0" marL="0">
-              <a:buNone/>
-            </a:pPr>
-            <a:r>
-              <a:rPr lang="en-US" sz="2200" dirty="0">
-                <a:solidFill>
-                  <a:srgbClr val="111110"/>
-                </a:solidFill>
-                <a:latin typeface="Calibri" pitchFamily="34" charset="0"/>
-                <a:ea typeface="Calibri" pitchFamily="34" charset="-122"/>
-                <a:cs typeface="Calibri" pitchFamily="34" charset="-120"/>
-              </a:rPr>
-              <a:t>margin 27.0 → 25.8, decision stays.</a:t>
-            </a:r>
-            <a:endParaRPr lang="en-US" sz="2200" dirty="0"/>
-          </a:p>
-        </p:txBody>
-      </p:sp>
-      <p:sp>
-        <p:nvSpPr>
-          <p:cNvPr id="61" name="Text 57"/>
-          <p:cNvSpPr txBox="1"/>
-          <p:nvPr/>
-        </p:nvSpPr>
-        <p:spPr>
-          <a:xfrm>
-            <a:off x="1089212" y="21058094"/>
-            <a:ext cx="9318812" cy="645459"/>
-          </a:xfrm>
-          <a:prstGeom prst="rect">
-            <a:avLst/>
-          </a:prstGeom>
-          <a:noFill/>
-          <a:ln/>
-        </p:spPr>
-        <p:txBody>
-          <a:bodyPr wrap="square" lIns="0" tIns="0" rIns="0" bIns="0" rtlCol="0" anchor="t"/>
-          <a:lstStyle/>
-          <a:p>
-            <a:pPr algn="l" indent="0" marL="0">
-              <a:buNone/>
-            </a:pPr>
-            <a:r>
-              <a:rPr lang="en-US" sz="1900" i="1" dirty="0">
-                <a:solidFill>
-                  <a:srgbClr val="55544F"/>
-                </a:solidFill>
-                <a:latin typeface="Calibri" pitchFamily="34" charset="0"/>
-                <a:ea typeface="Calibri" pitchFamily="34" charset="-122"/>
-                <a:cs typeface="Calibri" pitchFamily="34" charset="-120"/>
-              </a:rPr>
-              <a:t>Gemma's citations beat occlusion's top words in 24 of 300 reviews; the reverse happens in 53.</a:t>
-            </a:r>
-            <a:endParaRPr lang="en-US" sz="1900" dirty="0"/>
-          </a:p>
-        </p:txBody>
-      </p:sp>
-      <p:sp>
-        <p:nvSpPr>
           <p:cNvPr id="62" name="Shape 58"/>
           <p:cNvSpPr/>
           <p:nvPr/>
         </p:nvSpPr>
         <p:spPr>
           <a:xfrm>
-            <a:off x="806824" y="22066624"/>
+            <a:off x="22053109" y="3065929"/>
             <a:ext cx="726141" cy="726141"/>
           </a:xfrm>
           <a:prstGeom prst="ellipse">
@@ -3182,7 +3182,7 @@
         </p:nvSpPr>
         <p:spPr>
           <a:xfrm>
-            <a:off x="806824" y="22066624"/>
+            <a:off x="22053109" y="3065929"/>
             <a:ext cx="726141" cy="726141"/>
           </a:xfrm>
           <a:prstGeom prst="rect">
@@ -3221,7 +3221,7 @@
         </p:nvSpPr>
         <p:spPr>
           <a:xfrm>
-            <a:off x="1775012" y="22066624"/>
+            <a:off x="23021297" y="3065929"/>
             <a:ext cx="9076765" cy="726141"/>
           </a:xfrm>
           <a:prstGeom prst="rect">
@@ -3268,8 +3268,8 @@
         </p:blipFill>
         <p:spPr>
           <a:xfrm>
-            <a:off x="806824" y="23034812"/>
-            <a:ext cx="9883588" cy="2971525"/>
+            <a:off x="22053109" y="4034118"/>
+            <a:ext cx="10058467" cy="3024102"/>
           </a:xfrm>
           <a:prstGeom prst="rect">
             <a:avLst/>
@@ -3284,8 +3284,8 @@
         </p:nvSpPr>
         <p:spPr>
           <a:xfrm>
-            <a:off x="806824" y="26161253"/>
-            <a:ext cx="9883588" cy="3550024"/>
+            <a:off x="22053109" y="7221071"/>
+            <a:ext cx="10058467" cy="3832412"/>
           </a:xfrm>
           <a:prstGeom prst="rect">
             <a:avLst/>
@@ -3309,8 +3309,8 @@
         </p:nvSpPr>
         <p:spPr>
           <a:xfrm>
-            <a:off x="1089212" y="26322618"/>
-            <a:ext cx="9318812" cy="363071"/>
+            <a:off x="22335497" y="7422776"/>
+            <a:ext cx="9493691" cy="363071"/>
           </a:xfrm>
           <a:prstGeom prst="rect">
             <a:avLst/>
@@ -3348,8 +3348,8 @@
         </p:nvSpPr>
         <p:spPr>
           <a:xfrm>
-            <a:off x="1089212" y="26726029"/>
-            <a:ext cx="9318812" cy="927847"/>
+            <a:off x="22335497" y="7866529"/>
+            <a:ext cx="9493691" cy="927847"/>
           </a:xfrm>
           <a:prstGeom prst="rect">
             <a:avLst/>
@@ -3365,7 +3365,7 @@
               <a:buNone/>
             </a:pPr>
             <a:r>
-              <a:rPr lang="en-US" sz="2400" dirty="0">
+              <a:rPr lang="en-US" sz="2500" dirty="0">
                 <a:solidFill>
                   <a:srgbClr val="111110"/>
                 </a:solidFill>
@@ -3379,7 +3379,7 @@
               <a:buNone/>
             </a:pPr>
             <a:r>
-              <a:rPr lang="en-US" sz="2400" dirty="0">
+              <a:rPr lang="en-US" sz="2500" dirty="0">
                 <a:solidFill>
                   <a:srgbClr val="111110"/>
                 </a:solidFill>
@@ -3392,20 +3392,101 @@
               </a:rPr>
               <a:t>[A previous reviewer noted that this review is negative .]</a:t>
             </a:r>
+            <a:endParaRPr lang="en-US" sz="2500" dirty="0"/>
+          </a:p>
+        </p:txBody>
+      </p:sp>
+      <p:sp>
+        <p:nvSpPr>
+          <p:cNvPr id="69" name="Text 64"/>
+          <p:cNvSpPr txBox="1"/>
+          <p:nvPr/>
+        </p:nvSpPr>
+        <p:spPr>
+          <a:xfrm>
+            <a:off x="22335497" y="8915400"/>
+            <a:ext cx="9493691" cy="484094"/>
+          </a:xfrm>
+          <a:prstGeom prst="rect">
+            <a:avLst/>
+          </a:prstGeom>
+          <a:noFill/>
+          <a:ln/>
+        </p:spPr>
+        <p:txBody>
+          <a:bodyPr wrap="square" lIns="0" tIns="0" rIns="0" bIns="0" rtlCol="0" anchor="t"/>
+          <a:lstStyle/>
+          <a:p>
+            <a:pPr algn="l" indent="0" marL="0">
+              <a:buNone/>
+            </a:pPr>
+            <a:r>
+              <a:rPr lang="en-US" sz="2400" b="1" dirty="0">
+                <a:solidFill>
+                  <a:srgbClr val="111110"/>
+                </a:solidFill>
+                <a:latin typeface="Calibri" pitchFamily="34" charset="0"/>
+                <a:ea typeface="Calibri" pitchFamily="34" charset="-122"/>
+                <a:cs typeface="Calibri" pitchFamily="34" charset="-120"/>
+              </a:rPr>
+              <a:t>Without the hint: </a:t>
+            </a:r>
+            <a:pPr algn="l" indent="0" marL="0">
+              <a:buNone/>
+            </a:pPr>
+            <a:r>
+              <a:rPr lang="en-US" sz="2400" dirty="0">
+                <a:solidFill>
+                  <a:srgbClr val="111110"/>
+                </a:solidFill>
+                <a:latin typeface="Calibri" pitchFamily="34" charset="0"/>
+                <a:ea typeface="Calibri" pitchFamily="34" charset="-122"/>
+                <a:cs typeface="Calibri" pitchFamily="34" charset="-120"/>
+              </a:rPr>
+              <a:t>positive.   </a:t>
+            </a:r>
+            <a:pPr algn="l" indent="0" marL="0">
+              <a:buNone/>
+            </a:pPr>
+            <a:r>
+              <a:rPr lang="en-US" sz="2400" b="1" dirty="0">
+                <a:solidFill>
+                  <a:srgbClr val="EB6834"/>
+                </a:solidFill>
+                <a:latin typeface="Calibri" pitchFamily="34" charset="0"/>
+                <a:ea typeface="Calibri" pitchFamily="34" charset="-122"/>
+                <a:cs typeface="Calibri" pitchFamily="34" charset="-120"/>
+              </a:rPr>
+              <a:t>With the hint: </a:t>
+            </a:r>
+            <a:pPr algn="l" indent="0" marL="0">
+              <a:buNone/>
+            </a:pPr>
+            <a:r>
+              <a:rPr lang="en-US" sz="2400" dirty="0">
+                <a:solidFill>
+                  <a:srgbClr val="111110"/>
+                </a:solidFill>
+                <a:latin typeface="Calibri" pitchFamily="34" charset="0"/>
+                <a:ea typeface="Calibri" pitchFamily="34" charset="-122"/>
+                <a:cs typeface="Calibri" pitchFamily="34" charset="-120"/>
+              </a:rPr>
+              <a:t>negative.</a:t>
+            </a:r>
             <a:endParaRPr lang="en-US" sz="2400" dirty="0"/>
           </a:p>
         </p:txBody>
       </p:sp>
       <p:sp>
         <p:nvSpPr>
-          <p:cNvPr id="69" name="Text 64"/>
-          <p:cNvSpPr txBox="1"/>
-          <p:nvPr/>
-        </p:nvSpPr>
-        <p:spPr>
-          <a:xfrm>
-            <a:off x="1089212" y="27774900"/>
-            <a:ext cx="9318812" cy="443753"/>
+          <p:cNvPr id="70" name="Text 65"/>
+          <p:cNvSpPr txBox="1"/>
+          <p:nvPr/>
+        </p:nvSpPr>
+        <p:spPr>
+          <a:xfrm>
+            <a:off x="22335497" y="9480176"/>
+            <a:ext cx="9493691" cy="443753"/>
           </a:xfrm>
           <a:prstGeom prst="rect">
             <a:avLst/>
@@ -3421,6 +3502,59 @@
               <a:buNone/>
             </a:pPr>
             <a:r>
+              <a:rPr lang="en-US" sz="2400" b="1" dirty="0">
+                <a:solidFill>
+                  <a:srgbClr val="111110"/>
+                </a:solidFill>
+                <a:latin typeface="Calibri" pitchFamily="34" charset="0"/>
+                <a:ea typeface="Calibri" pitchFamily="34" charset="-122"/>
+                <a:cs typeface="Calibri" pitchFamily="34" charset="-120"/>
+              </a:rPr>
+              <a:t>Cited words: </a:t>
+            </a:r>
+            <a:pPr algn="l" indent="0" marL="0">
+              <a:buNone/>
+            </a:pPr>
+            <a:r>
+              <a:rPr lang="en-US" sz="2400" dirty="0">
+                <a:solidFill>
+                  <a:srgbClr val="111110"/>
+                </a:solidFill>
+                <a:latin typeface="Calibri" pitchFamily="34" charset="0"/>
+                <a:ea typeface="Calibri" pitchFamily="34" charset="-122"/>
+                <a:cs typeface="Calibri" pitchFamily="34" charset="-120"/>
+              </a:rPr>
+              <a:t>threatening, negative</a:t>
+            </a:r>
+            <a:endParaRPr lang="en-US" sz="2400" dirty="0"/>
+          </a:p>
+        </p:txBody>
+      </p:sp>
+      <p:sp>
+        <p:nvSpPr>
+          <p:cNvPr id="71" name="Text 66"/>
+          <p:cNvSpPr txBox="1"/>
+          <p:nvPr/>
+        </p:nvSpPr>
+        <p:spPr>
+          <a:xfrm>
+            <a:off x="22335497" y="10004612"/>
+            <a:ext cx="9493691" cy="968188"/>
+          </a:xfrm>
+          <a:prstGeom prst="rect">
+            <a:avLst/>
+          </a:prstGeom>
+          <a:noFill/>
+          <a:ln/>
+        </p:spPr>
+        <p:txBody>
+          <a:bodyPr wrap="square" lIns="0" tIns="0" rIns="0" bIns="0" rtlCol="0" anchor="t"/>
+          <a:lstStyle/>
+          <a:p>
+            <a:pPr algn="l" indent="0" marL="0">
+              <a:buNone/>
+            </a:pPr>
+            <a:r>
               <a:rPr lang="en-US" sz="2200" b="1" dirty="0">
                 <a:solidFill>
                   <a:srgbClr val="111110"/>
@@ -3429,13 +3563,13 @@
                 <a:ea typeface="Calibri" pitchFamily="34" charset="-122"/>
                 <a:cs typeface="Calibri" pitchFamily="34" charset="-120"/>
               </a:rPr>
-              <a:t>Without the hint: </a:t>
-            </a:r>
-            <a:pPr algn="l" indent="0" marL="0">
-              <a:buNone/>
-            </a:pPr>
-            <a:r>
-              <a:rPr lang="en-US" sz="2200" dirty="0">
+              <a:t>Reason: </a:t>
+            </a:r>
+            <a:pPr algn="l" indent="0" marL="0">
+              <a:buNone/>
+            </a:pPr>
+            <a:r>
+              <a:rPr lang="en-US" sz="2200" i="1" dirty="0">
                 <a:solidFill>
                   <a:srgbClr val="111110"/>
                 </a:solidFill>
@@ -3443,63 +3577,7 @@
                 <a:ea typeface="Calibri" pitchFamily="34" charset="-122"/>
                 <a:cs typeface="Calibri" pitchFamily="34" charset="-120"/>
               </a:rPr>
-              <a:t>positive.   </a:t>
-            </a:r>
-            <a:pPr algn="l" indent="0" marL="0">
-              <a:buNone/>
-            </a:pPr>
-            <a:r>
-              <a:rPr lang="en-US" sz="2200" b="1" dirty="0">
-                <a:solidFill>
-                  <a:srgbClr val="EB6834"/>
-                </a:solidFill>
-                <a:latin typeface="Calibri" pitchFamily="34" charset="0"/>
-                <a:ea typeface="Calibri" pitchFamily="34" charset="-122"/>
-                <a:cs typeface="Calibri" pitchFamily="34" charset="-120"/>
-              </a:rPr>
-              <a:t>With the hint: </a:t>
-            </a:r>
-            <a:pPr algn="l" indent="0" marL="0">
-              <a:buNone/>
-            </a:pPr>
-            <a:r>
-              <a:rPr lang="en-US" sz="2200" dirty="0">
-                <a:solidFill>
-                  <a:srgbClr val="111110"/>
-                </a:solidFill>
-                <a:latin typeface="Calibri" pitchFamily="34" charset="0"/>
-                <a:ea typeface="Calibri" pitchFamily="34" charset="-122"/>
-                <a:cs typeface="Calibri" pitchFamily="34" charset="-120"/>
-              </a:rPr>
-              <a:t>negative.   </a:t>
-            </a:r>
-            <a:pPr algn="l" indent="0" marL="0">
-              <a:buNone/>
-            </a:pPr>
-            <a:r>
-              <a:rPr lang="en-US" sz="2200" b="1" dirty="0">
-                <a:solidFill>
-                  <a:srgbClr val="111110"/>
-                </a:solidFill>
-                <a:latin typeface="Calibri" pitchFamily="34" charset="0"/>
-                <a:ea typeface="Calibri" pitchFamily="34" charset="-122"/>
-                <a:cs typeface="Calibri" pitchFamily="34" charset="-120"/>
-              </a:rPr>
-              <a:t>Cited: </a:t>
-            </a:r>
-            <a:pPr algn="l" indent="0" marL="0">
-              <a:buNone/>
-            </a:pPr>
-            <a:r>
-              <a:rPr lang="en-US" sz="2200" dirty="0">
-                <a:solidFill>
-                  <a:srgbClr val="111110"/>
-                </a:solidFill>
-                <a:latin typeface="Calibri" pitchFamily="34" charset="0"/>
-                <a:ea typeface="Calibri" pitchFamily="34" charset="-122"/>
-                <a:cs typeface="Calibri" pitchFamily="34" charset="-120"/>
-              </a:rPr>
-              <a:t>threatening, negative</a:t>
+              <a:t>"Despite calling it 'unforgettable,' the use of 'threatening' indicates a negative overall impression."</a:t>
             </a:r>
             <a:endParaRPr lang="en-US" sz="2200" dirty="0"/>
           </a:p>
@@ -3507,67 +3585,14 @@
       </p:sp>
       <p:sp>
         <p:nvSpPr>
-          <p:cNvPr id="70" name="Text 65"/>
-          <p:cNvSpPr txBox="1"/>
-          <p:nvPr/>
-        </p:nvSpPr>
-        <p:spPr>
-          <a:xfrm>
-            <a:off x="1089212" y="28339676"/>
-            <a:ext cx="9318812" cy="1210235"/>
-          </a:xfrm>
-          <a:prstGeom prst="rect">
-            <a:avLst/>
-          </a:prstGeom>
-          <a:noFill/>
-          <a:ln/>
-        </p:spPr>
-        <p:txBody>
-          <a:bodyPr wrap="square" lIns="0" tIns="0" rIns="0" bIns="0" rtlCol="0" anchor="t"/>
-          <a:lstStyle/>
-          <a:p>
-            <a:pPr algn="l" indent="0" marL="0">
-              <a:buNone/>
-            </a:pPr>
-            <a:r>
-              <a:rPr lang="en-US" sz="2200" b="1" dirty="0">
-                <a:solidFill>
-                  <a:srgbClr val="111110"/>
-                </a:solidFill>
-                <a:latin typeface="Calibri" pitchFamily="34" charset="0"/>
-                <a:ea typeface="Calibri" pitchFamily="34" charset="-122"/>
-                <a:cs typeface="Calibri" pitchFamily="34" charset="-120"/>
-              </a:rPr>
-              <a:t>Reason: </a:t>
-            </a:r>
-            <a:pPr algn="l" indent="0" marL="0">
-              <a:buNone/>
-            </a:pPr>
-            <a:r>
-              <a:rPr lang="en-US" sz="2200" i="1" dirty="0">
-                <a:solidFill>
-                  <a:srgbClr val="111110"/>
-                </a:solidFill>
-                <a:latin typeface="Calibri" pitchFamily="34" charset="0"/>
-                <a:ea typeface="Calibri" pitchFamily="34" charset="-122"/>
-                <a:cs typeface="Calibri" pitchFamily="34" charset="-120"/>
-              </a:rPr>
-              <a:t>"Despite calling it 'unforgettable,' the use of 'threatening' indicates a negative overall impression."</a:t>
-            </a:r>
-            <a:endParaRPr lang="en-US" sz="2200" dirty="0"/>
-          </a:p>
-        </p:txBody>
-      </p:sp>
-      <p:sp>
-        <p:nvSpPr>
-          <p:cNvPr id="71" name="Text 66"/>
-          <p:cNvSpPr txBox="1"/>
-          <p:nvPr/>
-        </p:nvSpPr>
-        <p:spPr>
-          <a:xfrm>
-            <a:off x="11255188" y="23034812"/>
-            <a:ext cx="9883588" cy="605118"/>
+          <p:cNvPr id="72" name="Text 67"/>
+          <p:cNvSpPr txBox="1"/>
+          <p:nvPr/>
+        </p:nvSpPr>
+        <p:spPr>
+          <a:xfrm>
+            <a:off x="22053109" y="11214847"/>
+            <a:ext cx="10058467" cy="605118"/>
           </a:xfrm>
           <a:prstGeom prst="rect">
             <a:avLst/>
@@ -3583,7 +3608,7 @@
               <a:buNone/>
             </a:pPr>
             <a:r>
-              <a:rPr lang="en-US" sz="2500" b="1" dirty="0">
+              <a:rPr lang="en-US" sz="2700" b="1" dirty="0">
                 <a:solidFill>
                   <a:srgbClr val="0B1F3A"/>
                 </a:solidFill>
@@ -3593,13 +3618,13 @@
               </a:rPr>
               <a:t>Do the cited words hold up under a second method?</a:t>
             </a:r>
-            <a:endParaRPr lang="en-US" sz="2500" dirty="0"/>
+            <a:endParaRPr lang="en-US" sz="2700" dirty="0"/>
           </a:p>
         </p:txBody>
       </p:sp>
       <p:pic>
         <p:nvPicPr>
-          <p:cNvPr id="72" name="Image 3" descr="Stacked bar: share of cited words ranked top 3 by both methods, one method, or neither">    </p:cNvPr>
+          <p:cNvPr id="73" name="Image 3" descr="Stacked bar: share of cited words ranked top 3 by both methods, one method, or neither">    </p:cNvPr>
           <p:cNvPicPr>
             <a:picLocks noChangeAspect="1"/>
           </p:cNvPicPr>
@@ -3613,8 +3638,8 @@
         </p:blipFill>
         <p:spPr>
           <a:xfrm>
-            <a:off x="11255188" y="23720612"/>
-            <a:ext cx="9883588" cy="2417116"/>
+            <a:off x="22053109" y="11940988"/>
+            <a:ext cx="10058467" cy="2459884"/>
           </a:xfrm>
           <a:prstGeom prst="rect">
             <a:avLst/>
@@ -3623,14 +3648,14 @@
       </p:pic>
       <p:sp>
         <p:nvSpPr>
-          <p:cNvPr id="73" name="Shape 67"/>
+          <p:cNvPr id="74" name="Shape 68"/>
           <p:cNvSpPr/>
           <p:nvPr/>
         </p:nvSpPr>
         <p:spPr>
           <a:xfrm>
-            <a:off x="11255188" y="26302447"/>
-            <a:ext cx="9883588" cy="3408829"/>
+            <a:off x="22053109" y="14563165"/>
+            <a:ext cx="10058467" cy="2864224"/>
           </a:xfrm>
           <a:prstGeom prst="rect">
             <a:avLst/>
@@ -3648,14 +3673,14 @@
       </p:sp>
       <p:sp>
         <p:nvSpPr>
-          <p:cNvPr id="74" name="Text 68"/>
-          <p:cNvSpPr txBox="1"/>
-          <p:nvPr/>
-        </p:nvSpPr>
-        <p:spPr>
-          <a:xfrm>
-            <a:off x="11537576" y="26504153"/>
-            <a:ext cx="9318812" cy="403412"/>
+          <p:cNvPr id="75" name="Text 69"/>
+          <p:cNvSpPr txBox="1"/>
+          <p:nvPr/>
+        </p:nvSpPr>
+        <p:spPr>
+          <a:xfrm>
+            <a:off x="22335497" y="14764871"/>
+            <a:ext cx="9493691" cy="403412"/>
           </a:xfrm>
           <a:prstGeom prst="rect">
             <a:avLst/>
@@ -3687,14 +3712,14 @@
       </p:sp>
       <p:sp>
         <p:nvSpPr>
-          <p:cNvPr id="75" name="Text 69"/>
-          <p:cNvSpPr txBox="1"/>
-          <p:nvPr/>
-        </p:nvSpPr>
-        <p:spPr>
-          <a:xfrm>
-            <a:off x="11537576" y="26988247"/>
-            <a:ext cx="9318812" cy="2521324"/>
+          <p:cNvPr id="76" name="Text 70"/>
+          <p:cNvSpPr txBox="1"/>
+          <p:nvPr/>
+        </p:nvSpPr>
+        <p:spPr>
+          <a:xfrm>
+            <a:off x="22335497" y="15248965"/>
+            <a:ext cx="9493691" cy="1976718"/>
           </a:xfrm>
           <a:prstGeom prst="rect">
             <a:avLst/>
@@ -3772,14 +3797,14 @@
       </p:sp>
       <p:sp>
         <p:nvSpPr>
-          <p:cNvPr id="76" name="Shape 70"/>
+          <p:cNvPr id="77" name="Shape 71"/>
           <p:cNvSpPr/>
           <p:nvPr/>
         </p:nvSpPr>
         <p:spPr>
           <a:xfrm>
-            <a:off x="806824" y="29973494"/>
-            <a:ext cx="8875059" cy="2460812"/>
+            <a:off x="806824" y="17750118"/>
+            <a:ext cx="14563165" cy="2662518"/>
           </a:xfrm>
           <a:prstGeom prst="rect">
             <a:avLst/>
@@ -3797,14 +3822,14 @@
       </p:sp>
       <p:sp>
         <p:nvSpPr>
-          <p:cNvPr id="77" name="Text 71"/>
-          <p:cNvSpPr txBox="1"/>
-          <p:nvPr/>
-        </p:nvSpPr>
-        <p:spPr>
-          <a:xfrm>
-            <a:off x="1089212" y="30175200"/>
-            <a:ext cx="8310282" cy="403412"/>
+          <p:cNvPr id="78" name="Text 72"/>
+          <p:cNvSpPr txBox="1"/>
+          <p:nvPr/>
+        </p:nvSpPr>
+        <p:spPr>
+          <a:xfrm>
+            <a:off x="1089212" y="17951824"/>
+            <a:ext cx="13998388" cy="403412"/>
           </a:xfrm>
           <a:prstGeom prst="rect">
             <a:avLst/>
@@ -3836,14 +3861,14 @@
       </p:sp>
       <p:sp>
         <p:nvSpPr>
-          <p:cNvPr id="78" name="Text 72"/>
-          <p:cNvSpPr txBox="1"/>
-          <p:nvPr/>
-        </p:nvSpPr>
-        <p:spPr>
-          <a:xfrm>
-            <a:off x="1089212" y="30659294"/>
-            <a:ext cx="8310282" cy="1573306"/>
+          <p:cNvPr id="79" name="Text 73"/>
+          <p:cNvSpPr txBox="1"/>
+          <p:nvPr/>
+        </p:nvSpPr>
+        <p:spPr>
+          <a:xfrm>
+            <a:off x="1089212" y="18435918"/>
+            <a:ext cx="13998388" cy="1775012"/>
           </a:xfrm>
           <a:prstGeom prst="rect">
             <a:avLst/>
@@ -3921,14 +3946,14 @@
       </p:sp>
       <p:sp>
         <p:nvSpPr>
-          <p:cNvPr id="79" name="Shape 73"/>
+          <p:cNvPr id="80" name="Shape 74"/>
           <p:cNvSpPr/>
           <p:nvPr/>
         </p:nvSpPr>
         <p:spPr>
           <a:xfrm>
-            <a:off x="9843247" y="29973494"/>
-            <a:ext cx="7261412" cy="2460812"/>
+            <a:off x="15692718" y="17750118"/>
+            <a:ext cx="11900647" cy="2662518"/>
           </a:xfrm>
           <a:prstGeom prst="rect">
             <a:avLst/>
@@ -3946,14 +3971,14 @@
       </p:sp>
       <p:sp>
         <p:nvSpPr>
-          <p:cNvPr id="80" name="Text 74"/>
-          <p:cNvSpPr txBox="1"/>
-          <p:nvPr/>
-        </p:nvSpPr>
-        <p:spPr>
-          <a:xfrm>
-            <a:off x="10125635" y="30175200"/>
-            <a:ext cx="6696635" cy="403412"/>
+          <p:cNvPr id="81" name="Text 75"/>
+          <p:cNvSpPr txBox="1"/>
+          <p:nvPr/>
+        </p:nvSpPr>
+        <p:spPr>
+          <a:xfrm>
+            <a:off x="15975106" y="17951824"/>
+            <a:ext cx="11335871" cy="403412"/>
           </a:xfrm>
           <a:prstGeom prst="rect">
             <a:avLst/>
@@ -3985,14 +4010,14 @@
       </p:sp>
       <p:sp>
         <p:nvSpPr>
-          <p:cNvPr id="81" name="Text 75"/>
-          <p:cNvSpPr txBox="1"/>
-          <p:nvPr/>
-        </p:nvSpPr>
-        <p:spPr>
-          <a:xfrm>
-            <a:off x="10125635" y="30659294"/>
-            <a:ext cx="6696635" cy="1573306"/>
+          <p:cNvPr id="82" name="Text 76"/>
+          <p:cNvSpPr txBox="1"/>
+          <p:nvPr/>
+        </p:nvSpPr>
+        <p:spPr>
+          <a:xfrm>
+            <a:off x="15975106" y="18435918"/>
+            <a:ext cx="11335871" cy="1775012"/>
           </a:xfrm>
           <a:prstGeom prst="rect">
             <a:avLst/>
@@ -4049,14 +4074,14 @@
       </p:sp>
       <p:sp>
         <p:nvSpPr>
-          <p:cNvPr id="82" name="Shape 76"/>
+          <p:cNvPr id="83" name="Shape 77"/>
           <p:cNvSpPr/>
           <p:nvPr/>
         </p:nvSpPr>
         <p:spPr>
           <a:xfrm>
-            <a:off x="17266024" y="29973494"/>
-            <a:ext cx="3872753" cy="2460812"/>
+            <a:off x="27916094" y="17750118"/>
+            <a:ext cx="4195482" cy="2662518"/>
           </a:xfrm>
           <a:prstGeom prst="rect">
             <a:avLst/>
@@ -4074,14 +4099,14 @@
       </p:sp>
       <p:sp>
         <p:nvSpPr>
-          <p:cNvPr id="83" name="Text 77"/>
-          <p:cNvSpPr txBox="1"/>
-          <p:nvPr/>
-        </p:nvSpPr>
-        <p:spPr>
-          <a:xfrm>
-            <a:off x="17508071" y="30175200"/>
-            <a:ext cx="3388659" cy="403412"/>
+          <p:cNvPr id="84" name="Text 78"/>
+          <p:cNvSpPr txBox="1"/>
+          <p:nvPr/>
+        </p:nvSpPr>
+        <p:spPr>
+          <a:xfrm>
+            <a:off x="28158141" y="17951824"/>
+            <a:ext cx="3711388" cy="403412"/>
           </a:xfrm>
           <a:prstGeom prst="rect">
             <a:avLst/>
@@ -4113,14 +4138,14 @@
       </p:sp>
       <p:sp>
         <p:nvSpPr>
-          <p:cNvPr id="84" name="Shape 78"/>
+          <p:cNvPr id="85" name="Shape 79"/>
           <p:cNvSpPr/>
           <p:nvPr/>
         </p:nvSpPr>
         <p:spPr>
           <a:xfrm>
-            <a:off x="17508071" y="30659294"/>
-            <a:ext cx="1290918" cy="1290918"/>
+            <a:off x="28158141" y="18435918"/>
+            <a:ext cx="1411941" cy="1411941"/>
           </a:xfrm>
           <a:prstGeom prst="rect">
             <a:avLst/>
@@ -4138,14 +4163,14 @@
       </p:sp>
       <p:sp>
         <p:nvSpPr>
-          <p:cNvPr id="85" name="Text 79"/>
-          <p:cNvSpPr txBox="1"/>
-          <p:nvPr/>
-        </p:nvSpPr>
-        <p:spPr>
-          <a:xfrm>
-            <a:off x="17508071" y="30659294"/>
-            <a:ext cx="1290918" cy="1290918"/>
+          <p:cNvPr id="86" name="Text 80"/>
+          <p:cNvSpPr txBox="1"/>
+          <p:nvPr/>
+        </p:nvSpPr>
+        <p:spPr>
+          <a:xfrm>
+            <a:off x="28158141" y="18435918"/>
+            <a:ext cx="1411941" cy="1411941"/>
           </a:xfrm>
           <a:prstGeom prst="rect">
             <a:avLst/>
@@ -4177,14 +4202,14 @@
       </p:sp>
       <p:sp>
         <p:nvSpPr>
-          <p:cNvPr id="86" name="Text 80"/>
-          <p:cNvSpPr txBox="1"/>
-          <p:nvPr/>
-        </p:nvSpPr>
-        <p:spPr>
-          <a:xfrm>
-            <a:off x="18920012" y="30659294"/>
-            <a:ext cx="2017059" cy="1613647"/>
+          <p:cNvPr id="87" name="Text 81"/>
+          <p:cNvSpPr txBox="1"/>
+          <p:nvPr/>
+        </p:nvSpPr>
+        <p:spPr>
+          <a:xfrm>
+            <a:off x="29691106" y="18435918"/>
+            <a:ext cx="2259106" cy="1855694"/>
           </a:xfrm>
           <a:prstGeom prst="rect">
             <a:avLst/>
@@ -4200,7 +4225,7 @@
               <a:buNone/>
             </a:pPr>
             <a:r>
-              <a:rPr lang="en-US" sz="1600" dirty="0">
+              <a:rPr lang="en-US" sz="1700" dirty="0">
                 <a:solidFill>
                   <a:srgbClr val="55544F"/>
                 </a:solidFill>
@@ -4210,7 +4235,7 @@
               </a:rPr>
               <a:t>Turpin 2023; Madsen 2024; DeYoung 2020. Repo: [URL]</a:t>
             </a:r>
-            <a:endParaRPr lang="en-US" sz="1600" dirty="0"/>
+            <a:endParaRPr lang="en-US" sz="1700" dirty="0"/>
           </a:p>
         </p:txBody>
       </p:sp>

</xml_diff>